<commit_message>
feat: LLM restyle mode (BYO Claude key in browser) picks brand layout per slide + rewrites content (tiles/columns/image+text); heuristic fallback; template regains layout donors
</commit_message>
<xml_diff>
--- a/engine/assets/guidelines.pptx
+++ b/engine/assets/guidelines.pptx
@@ -11,6 +11,10 @@
     <p:sldId id="271" r:id="rId22"/>
     <p:sldId id="276" r:id="rId27"/>
     <p:sldId id="292" r:id="rId43"/>
+    <p:sldId id="303" r:id="rId54"/>
+    <p:sldId id="306" r:id="rId57"/>
+    <p:sldId id="323" r:id="rId74"/>
+    <p:sldId id="342" r:id="rId93"/>
     <p:sldId id="361" r:id="rId112"/>
   </p:sldIdLst>
   <p:sldSz cy="5143500" cx="9144000"/>
@@ -6124,6 +6128,1680 @@
 </p:sld>
 </file>
 
+<file path=ppt/slides/slide48.xml><?xml version="1.0" encoding="utf-8"?>
+<p:sld xmlns:a="http://schemas.openxmlformats.org/drawingml/2006/main" xmlns:r="http://schemas.openxmlformats.org/officeDocument/2006/relationships" xmlns:mc="http://schemas.openxmlformats.org/markup-compatibility/2006" xmlns:mv="urn:schemas-microsoft-com:mac:vml" xmlns:p="http://schemas.openxmlformats.org/presentationml/2006/main" xmlns:c="http://schemas.openxmlformats.org/drawingml/2006/chart" xmlns:dgm="http://schemas.openxmlformats.org/drawingml/2006/diagram" xmlns:o="urn:schemas-microsoft-com:office:office" xmlns:v="urn:schemas-microsoft-com:vml" xmlns:pvml="urn:schemas-microsoft-com:office:powerpoint" xmlns:com="http://schemas.openxmlformats.org/drawingml/2006/compatibility" xmlns:p14="http://schemas.microsoft.com/office/powerpoint/2010/main" xmlns:p15="http://schemas.microsoft.com/office/powerpoint/2012/main" xmlns:ahyp="http://schemas.microsoft.com/office/drawing/2018/hyperlinkcolor">
+  <p:cSld>
+    <p:bg>
+      <p:bgPr>
+        <a:solidFill>
+          <a:srgbClr val="F2FAFF"/>
+        </a:solidFill>
+      </p:bgPr>
+    </p:bg>
+    <p:spTree>
+      <p:nvGrpSpPr>
+        <p:cNvPr id="397" name="Shape 397"/>
+        <p:cNvGrpSpPr/>
+        <p:nvPr/>
+      </p:nvGrpSpPr>
+      <p:grpSpPr>
+        <a:xfrm>
+          <a:off x="0" y="0"/>
+          <a:ext cx="0" cy="0"/>
+          <a:chOff x="0" y="0"/>
+          <a:chExt cx="0" cy="0"/>
+        </a:xfrm>
+      </p:grpSpPr>
+      <p:sp>
+        <p:nvSpPr>
+          <p:cNvPr id="398" name="Google Shape;398;p60"/>
+          <p:cNvSpPr txBox="1"/>
+          <p:nvPr/>
+        </p:nvSpPr>
+        <p:spPr>
+          <a:xfrm>
+            <a:off x="67675" y="84600"/>
+            <a:ext cx="6647700" cy="1169700"/>
+          </a:xfrm>
+          <a:prstGeom prst="rect">
+            <a:avLst/>
+          </a:prstGeom>
+          <a:noFill/>
+          <a:ln>
+            <a:noFill/>
+          </a:ln>
+        </p:spPr>
+        <p:txBody>
+          <a:bodyPr anchorCtr="0" anchor="t" bIns="91425" lIns="91425" spcFirstLastPara="1" rIns="91425" wrap="square" tIns="91425">
+            <a:spAutoFit/>
+          </a:bodyPr>
+          <a:lstStyle/>
+          <a:p>
+            <a:pPr indent="0" lvl="0" marL="0" rtl="0" algn="l">
+              <a:lnSpc>
+                <a:spcPct val="80000"/>
+              </a:lnSpc>
+              <a:spcBef>
+                <a:spcPts val="0"/>
+              </a:spcBef>
+              <a:spcAft>
+                <a:spcPts val="0"/>
+              </a:spcAft>
+              <a:buClr>
+                <a:schemeClr val="dk1"/>
+              </a:buClr>
+              <a:buSzPts val="1100"/>
+              <a:buFont typeface="Arial"/>
+              <a:buNone/>
+            </a:pPr>
+            <a:r>
+              <a:rPr b="1" lang="ru" sz="4000">
+                <a:solidFill>
+                  <a:srgbClr val="080040"/>
+                </a:solidFill>
+                <a:latin typeface="JetBrains Mono"/>
+                <a:ea typeface="JetBrains Mono"/>
+                <a:cs typeface="JetBrains Mono"/>
+                <a:sym typeface="JetBrains Mono"/>
+              </a:rPr>
+              <a:t>Крупный текст с подзаголовками</a:t>
+            </a:r>
+            <a:endParaRPr b="1" sz="4000">
+              <a:solidFill>
+                <a:srgbClr val="080040"/>
+              </a:solidFill>
+              <a:latin typeface="JetBrains Mono"/>
+              <a:ea typeface="JetBrains Mono"/>
+              <a:cs typeface="JetBrains Mono"/>
+              <a:sym typeface="JetBrains Mono"/>
+            </a:endParaRPr>
+          </a:p>
+        </p:txBody>
+      </p:sp>
+      <p:sp>
+        <p:nvSpPr>
+          <p:cNvPr id="399" name="Google Shape;399;p60"/>
+          <p:cNvSpPr txBox="1"/>
+          <p:nvPr/>
+        </p:nvSpPr>
+        <p:spPr>
+          <a:xfrm>
+            <a:off x="100750" y="1666875"/>
+            <a:ext cx="8852700" cy="3341700"/>
+          </a:xfrm>
+          <a:prstGeom prst="rect">
+            <a:avLst/>
+          </a:prstGeom>
+          <a:noFill/>
+          <a:ln>
+            <a:noFill/>
+          </a:ln>
+        </p:spPr>
+        <p:txBody>
+          <a:bodyPr anchorCtr="0" anchor="b" bIns="91425" lIns="91425" spcFirstLastPara="1" rIns="91425" wrap="square" tIns="91425">
+            <a:noAutofit/>
+          </a:bodyPr>
+          <a:lstStyle/>
+          <a:p>
+            <a:pPr indent="0" lvl="0" marL="0" rtl="0" algn="l">
+              <a:spcBef>
+                <a:spcPts val="0"/>
+              </a:spcBef>
+              <a:spcAft>
+                <a:spcPts val="0"/>
+              </a:spcAft>
+              <a:buClr>
+                <a:schemeClr val="dk1"/>
+              </a:buClr>
+              <a:buSzPts val="1100"/>
+              <a:buFont typeface="Arial"/>
+              <a:buNone/>
+            </a:pPr>
+            <a:r>
+              <a:rPr b="1" lang="ru" sz="2000">
+                <a:solidFill>
+                  <a:srgbClr val="FF067E"/>
+                </a:solidFill>
+                <a:latin typeface="Inter"/>
+                <a:ea typeface="Inter"/>
+                <a:cs typeface="Inter"/>
+                <a:sym typeface="Inter"/>
+              </a:rPr>
+              <a:t>Как передать максимальное количество информации?</a:t>
+            </a:r>
+            <a:br>
+              <a:rPr lang="ru" sz="2000">
+                <a:solidFill>
+                  <a:srgbClr val="080040"/>
+                </a:solidFill>
+                <a:latin typeface="Inter"/>
+                <a:ea typeface="Inter"/>
+                <a:cs typeface="Inter"/>
+                <a:sym typeface="Inter"/>
+              </a:rPr>
+            </a:br>
+            <a:r>
+              <a:rPr lang="ru" sz="2000">
+                <a:solidFill>
+                  <a:srgbClr val="080040"/>
+                </a:solidFill>
+                <a:latin typeface="Inter"/>
+                <a:ea typeface="Inter"/>
+                <a:cs typeface="Inter"/>
+                <a:sym typeface="Inter"/>
+              </a:rPr>
+              <a:t>Можно закачать информацию в свой телефон или распечатать небольшие карточки. Так вы будете выглядеть подготовленным в отличие от ситуации, когда вы читаете со слайда, развернувшись к зрителям боком или спиной.</a:t>
+            </a:r>
+            <a:endParaRPr sz="2000">
+              <a:solidFill>
+                <a:srgbClr val="080040"/>
+              </a:solidFill>
+              <a:latin typeface="Inter"/>
+              <a:ea typeface="Inter"/>
+              <a:cs typeface="Inter"/>
+              <a:sym typeface="Inter"/>
+            </a:endParaRPr>
+          </a:p>
+          <a:p>
+            <a:pPr indent="0" lvl="0" marL="0" rtl="0" algn="l">
+              <a:spcBef>
+                <a:spcPts val="1000"/>
+              </a:spcBef>
+              <a:spcAft>
+                <a:spcPts val="1000"/>
+              </a:spcAft>
+              <a:buNone/>
+            </a:pPr>
+            <a:r>
+              <a:rPr b="1" lang="ru" sz="2000">
+                <a:solidFill>
+                  <a:srgbClr val="FF067E"/>
+                </a:solidFill>
+                <a:latin typeface="Inter"/>
+                <a:ea typeface="Inter"/>
+                <a:cs typeface="Inter"/>
+                <a:sym typeface="Inter"/>
+              </a:rPr>
+              <a:t>Как передать максимальное количество информации?</a:t>
+            </a:r>
+            <a:br>
+              <a:rPr lang="ru" sz="2000">
+                <a:solidFill>
+                  <a:srgbClr val="080040"/>
+                </a:solidFill>
+                <a:latin typeface="Inter"/>
+                <a:ea typeface="Inter"/>
+                <a:cs typeface="Inter"/>
+                <a:sym typeface="Inter"/>
+              </a:rPr>
+            </a:br>
+            <a:r>
+              <a:rPr lang="ru" sz="2000">
+                <a:solidFill>
+                  <a:srgbClr val="080040"/>
+                </a:solidFill>
+                <a:latin typeface="Inter"/>
+                <a:ea typeface="Inter"/>
+                <a:cs typeface="Inter"/>
+                <a:sym typeface="Inter"/>
+              </a:rPr>
+              <a:t>Можно закачать информацию в свой телефон или распечатать небольшие карточки. Так вы будете выглядеть подготовленным в отличие от ситуации, когда вы читаете со слайда, развернувшись к зрителям боком или спиной.</a:t>
+            </a:r>
+            <a:endParaRPr sz="2000">
+              <a:solidFill>
+                <a:srgbClr val="080040"/>
+              </a:solidFill>
+              <a:latin typeface="Inter"/>
+              <a:ea typeface="Inter"/>
+              <a:cs typeface="Inter"/>
+              <a:sym typeface="Inter"/>
+            </a:endParaRPr>
+          </a:p>
+        </p:txBody>
+      </p:sp>
+      <p:sp>
+        <p:nvSpPr>
+          <p:cNvPr id="400" name="Google Shape;400;p60"/>
+          <p:cNvSpPr txBox="1"/>
+          <p:nvPr>
+            <p:ph idx="12" type="sldNum"/>
+          </p:nvPr>
+        </p:nvSpPr>
+        <p:spPr>
+          <a:xfrm>
+            <a:off x="96504" y="4840516"/>
+            <a:ext cx="548700" cy="393600"/>
+          </a:xfrm>
+          <a:prstGeom prst="rect">
+            <a:avLst/>
+          </a:prstGeom>
+        </p:spPr>
+        <p:txBody>
+          <a:bodyPr anchorCtr="0" anchor="ctr" bIns="91425" lIns="91425" spcFirstLastPara="1" rIns="91425" wrap="square" tIns="91425">
+            <a:normAutofit/>
+          </a:bodyPr>
+          <a:lstStyle/>
+          <a:p>
+            <a:pPr indent="0" lvl="0" marL="0" rtl="0" algn="l">
+              <a:spcBef>
+                <a:spcPts val="0"/>
+              </a:spcBef>
+              <a:spcAft>
+                <a:spcPts val="0"/>
+              </a:spcAft>
+              <a:buNone/>
+            </a:pPr>
+            <a:fld id="{00000000-1234-1234-1234-123412341234}" type="slidenum">
+              <a:rPr lang="ru">
+                <a:solidFill>
+                  <a:srgbClr val="D4D3E2"/>
+                </a:solidFill>
+              </a:rPr>
+              <a:t>‹#›</a:t>
+            </a:fld>
+            <a:endParaRPr>
+              <a:solidFill>
+                <a:srgbClr val="D4D3E2"/>
+              </a:solidFill>
+            </a:endParaRPr>
+          </a:p>
+        </p:txBody>
+      </p:sp>
+    </p:spTree>
+  </p:cSld>
+  <p:clrMapOvr>
+    <a:masterClrMapping/>
+  </p:clrMapOvr>
+</p:sld>
+</file>
+
+<file path=ppt/slides/slide51.xml><?xml version="1.0" encoding="utf-8"?>
+<p:sld xmlns:a="http://schemas.openxmlformats.org/drawingml/2006/main" xmlns:r="http://schemas.openxmlformats.org/officeDocument/2006/relationships" xmlns:mc="http://schemas.openxmlformats.org/markup-compatibility/2006" xmlns:mv="urn:schemas-microsoft-com:mac:vml" xmlns:p="http://schemas.openxmlformats.org/presentationml/2006/main" xmlns:c="http://schemas.openxmlformats.org/drawingml/2006/chart" xmlns:dgm="http://schemas.openxmlformats.org/drawingml/2006/diagram" xmlns:o="urn:schemas-microsoft-com:office:office" xmlns:v="urn:schemas-microsoft-com:vml" xmlns:pvml="urn:schemas-microsoft-com:office:powerpoint" xmlns:com="http://schemas.openxmlformats.org/drawingml/2006/compatibility" xmlns:p14="http://schemas.microsoft.com/office/powerpoint/2010/main" xmlns:p15="http://schemas.microsoft.com/office/powerpoint/2012/main" xmlns:ahyp="http://schemas.microsoft.com/office/drawing/2018/hyperlinkcolor">
+  <p:cSld>
+    <p:bg>
+      <p:bgPr>
+        <a:solidFill>
+          <a:srgbClr val="F2FAFF"/>
+        </a:solidFill>
+      </p:bgPr>
+    </p:bg>
+    <p:spTree>
+      <p:nvGrpSpPr>
+        <p:cNvPr id="419" name="Shape 419"/>
+        <p:cNvGrpSpPr/>
+        <p:nvPr/>
+      </p:nvGrpSpPr>
+      <p:grpSpPr>
+        <a:xfrm>
+          <a:off x="0" y="0"/>
+          <a:ext cx="0" cy="0"/>
+          <a:chOff x="0" y="0"/>
+          <a:chExt cx="0" cy="0"/>
+        </a:xfrm>
+      </p:grpSpPr>
+      <p:sp>
+        <p:nvSpPr>
+          <p:cNvPr id="420" name="Google Shape;420;p63"/>
+          <p:cNvSpPr txBox="1"/>
+          <p:nvPr/>
+        </p:nvSpPr>
+        <p:spPr>
+          <a:xfrm>
+            <a:off x="97375" y="1689211"/>
+            <a:ext cx="4379400" cy="3234900"/>
+          </a:xfrm>
+          <a:prstGeom prst="rect">
+            <a:avLst/>
+          </a:prstGeom>
+          <a:noFill/>
+          <a:ln>
+            <a:noFill/>
+          </a:ln>
+        </p:spPr>
+        <p:txBody>
+          <a:bodyPr anchorCtr="0" anchor="t" bIns="91425" lIns="91425" spcFirstLastPara="1" rIns="91425" wrap="square" tIns="91425">
+            <a:noAutofit/>
+          </a:bodyPr>
+          <a:lstStyle/>
+          <a:p>
+            <a:pPr indent="0" lvl="0" marL="0" rtl="0" algn="l">
+              <a:spcBef>
+                <a:spcPts val="0"/>
+              </a:spcBef>
+              <a:spcAft>
+                <a:spcPts val="0"/>
+              </a:spcAft>
+              <a:buNone/>
+            </a:pPr>
+            <a:r>
+              <a:rPr b="1" lang="ru">
+                <a:solidFill>
+                  <a:srgbClr val="FF067E"/>
+                </a:solidFill>
+                <a:latin typeface="Inter"/>
+                <a:ea typeface="Inter"/>
+                <a:cs typeface="Inter"/>
+                <a:sym typeface="Inter"/>
+              </a:rPr>
+              <a:t>Что делать, если нет времени учить?</a:t>
+            </a:r>
+            <a:br>
+              <a:rPr lang="ru">
+                <a:solidFill>
+                  <a:srgbClr val="080040"/>
+                </a:solidFill>
+                <a:latin typeface="Inter"/>
+                <a:ea typeface="Inter"/>
+                <a:cs typeface="Inter"/>
+                <a:sym typeface="Inter"/>
+              </a:rPr>
+            </a:br>
+            <a:r>
+              <a:rPr lang="ru">
+                <a:solidFill>
+                  <a:srgbClr val="080040"/>
+                </a:solidFill>
+                <a:latin typeface="Inter"/>
+                <a:ea typeface="Inter"/>
+                <a:cs typeface="Inter"/>
+                <a:sym typeface="Inter"/>
+              </a:rPr>
+              <a:t>Можно закачать информацию в свой телефон или распечатать небольшие карточки. Так вы будете выглядеть подготовленным в отличие от ситуации, когда вы читаете со слайда, развернувшись к зрителям боком или спиной.</a:t>
+            </a:r>
+            <a:endParaRPr>
+              <a:solidFill>
+                <a:srgbClr val="080040"/>
+              </a:solidFill>
+              <a:latin typeface="Inter"/>
+              <a:ea typeface="Inter"/>
+              <a:cs typeface="Inter"/>
+              <a:sym typeface="Inter"/>
+            </a:endParaRPr>
+          </a:p>
+          <a:p>
+            <a:pPr indent="0" lvl="0" marL="0" rtl="0" algn="l">
+              <a:spcBef>
+                <a:spcPts val="1000"/>
+              </a:spcBef>
+              <a:spcAft>
+                <a:spcPts val="1000"/>
+              </a:spcAft>
+              <a:buNone/>
+            </a:pPr>
+            <a:r>
+              <a:rPr b="1" lang="ru">
+                <a:solidFill>
+                  <a:srgbClr val="FF067E"/>
+                </a:solidFill>
+                <a:latin typeface="Inter"/>
+                <a:ea typeface="Inter"/>
+                <a:cs typeface="Inter"/>
+                <a:sym typeface="Inter"/>
+              </a:rPr>
+              <a:t>Почему чтение со слайдов — это проблема?</a:t>
+            </a:r>
+            <a:br>
+              <a:rPr lang="ru">
+                <a:solidFill>
+                  <a:srgbClr val="080040"/>
+                </a:solidFill>
+                <a:latin typeface="Inter"/>
+                <a:ea typeface="Inter"/>
+                <a:cs typeface="Inter"/>
+                <a:sym typeface="Inter"/>
+              </a:rPr>
+            </a:br>
+            <a:r>
+              <a:rPr lang="ru">
+                <a:solidFill>
+                  <a:srgbClr val="080040"/>
+                </a:solidFill>
+                <a:latin typeface="Inter"/>
+                <a:ea typeface="Inter"/>
+                <a:cs typeface="Inter"/>
+                <a:sym typeface="Inter"/>
+              </a:rPr>
+              <a:t>Очень небольшой процент людей в мире может одновременно понимать информацию, читая и слушая. Это значит, что в зале будут люди, которые будут либо вас слушать, либо читать со слайда. В обоих случаях они будут раздражены, потому что почувствуют, что теряют часть важной информации.</a:t>
+            </a:r>
+            <a:endParaRPr>
+              <a:solidFill>
+                <a:srgbClr val="080040"/>
+              </a:solidFill>
+              <a:latin typeface="Inter"/>
+              <a:ea typeface="Inter"/>
+              <a:cs typeface="Inter"/>
+              <a:sym typeface="Inter"/>
+            </a:endParaRPr>
+          </a:p>
+        </p:txBody>
+      </p:sp>
+      <p:sp>
+        <p:nvSpPr>
+          <p:cNvPr id="421" name="Google Shape;421;p63"/>
+          <p:cNvSpPr txBox="1"/>
+          <p:nvPr/>
+        </p:nvSpPr>
+        <p:spPr>
+          <a:xfrm>
+            <a:off x="67675" y="84600"/>
+            <a:ext cx="6647700" cy="1169700"/>
+          </a:xfrm>
+          <a:prstGeom prst="rect">
+            <a:avLst/>
+          </a:prstGeom>
+          <a:noFill/>
+          <a:ln>
+            <a:noFill/>
+          </a:ln>
+        </p:spPr>
+        <p:txBody>
+          <a:bodyPr anchorCtr="0" anchor="t" bIns="91425" lIns="91425" spcFirstLastPara="1" rIns="91425" wrap="square" tIns="91425">
+            <a:spAutoFit/>
+          </a:bodyPr>
+          <a:lstStyle/>
+          <a:p>
+            <a:pPr indent="0" lvl="0" marL="0" rtl="0" algn="l">
+              <a:lnSpc>
+                <a:spcPct val="80000"/>
+              </a:lnSpc>
+              <a:spcBef>
+                <a:spcPts val="0"/>
+              </a:spcBef>
+              <a:spcAft>
+                <a:spcPts val="0"/>
+              </a:spcAft>
+              <a:buClr>
+                <a:schemeClr val="dk1"/>
+              </a:buClr>
+              <a:buSzPts val="1100"/>
+              <a:buFont typeface="Arial"/>
+              <a:buNone/>
+            </a:pPr>
+            <a:r>
+              <a:rPr b="1" lang="ru" sz="4000">
+                <a:solidFill>
+                  <a:srgbClr val="080040"/>
+                </a:solidFill>
+                <a:latin typeface="JetBrains Mono"/>
+                <a:ea typeface="JetBrains Mono"/>
+                <a:cs typeface="JetBrains Mono"/>
+                <a:sym typeface="JetBrains Mono"/>
+              </a:rPr>
+              <a:t>Маленький текст в колонках</a:t>
+            </a:r>
+            <a:endParaRPr b="1" sz="4000">
+              <a:solidFill>
+                <a:srgbClr val="080040"/>
+              </a:solidFill>
+              <a:latin typeface="JetBrains Mono"/>
+              <a:ea typeface="JetBrains Mono"/>
+              <a:cs typeface="JetBrains Mono"/>
+              <a:sym typeface="JetBrains Mono"/>
+            </a:endParaRPr>
+          </a:p>
+        </p:txBody>
+      </p:sp>
+      <p:sp>
+        <p:nvSpPr>
+          <p:cNvPr id="422" name="Google Shape;422;p63"/>
+          <p:cNvSpPr txBox="1"/>
+          <p:nvPr/>
+        </p:nvSpPr>
+        <p:spPr>
+          <a:xfrm>
+            <a:off x="4567225" y="1689200"/>
+            <a:ext cx="4379400" cy="3435300"/>
+          </a:xfrm>
+          <a:prstGeom prst="rect">
+            <a:avLst/>
+          </a:prstGeom>
+          <a:noFill/>
+          <a:ln>
+            <a:noFill/>
+          </a:ln>
+        </p:spPr>
+        <p:txBody>
+          <a:bodyPr anchorCtr="0" anchor="t" bIns="91425" lIns="91425" spcFirstLastPara="1" rIns="91425" wrap="square" tIns="91425">
+            <a:noAutofit/>
+          </a:bodyPr>
+          <a:lstStyle/>
+          <a:p>
+            <a:pPr indent="0" lvl="0" marL="0" rtl="0" algn="l">
+              <a:spcBef>
+                <a:spcPts val="0"/>
+              </a:spcBef>
+              <a:spcAft>
+                <a:spcPts val="0"/>
+              </a:spcAft>
+              <a:buNone/>
+            </a:pPr>
+            <a:r>
+              <a:rPr b="1" lang="ru">
+                <a:solidFill>
+                  <a:srgbClr val="FF067E"/>
+                </a:solidFill>
+                <a:latin typeface="Inter"/>
+                <a:ea typeface="Inter"/>
+                <a:cs typeface="Inter"/>
+                <a:sym typeface="Inter"/>
+              </a:rPr>
+              <a:t>Как передать максимальное количество информации?</a:t>
+            </a:r>
+            <a:br>
+              <a:rPr lang="ru">
+                <a:solidFill>
+                  <a:srgbClr val="080040"/>
+                </a:solidFill>
+                <a:latin typeface="Inter"/>
+                <a:ea typeface="Inter"/>
+                <a:cs typeface="Inter"/>
+                <a:sym typeface="Inter"/>
+              </a:rPr>
+            </a:br>
+            <a:r>
+              <a:rPr lang="ru">
+                <a:solidFill>
+                  <a:srgbClr val="080040"/>
+                </a:solidFill>
+                <a:latin typeface="Inter"/>
+                <a:ea typeface="Inter"/>
+                <a:cs typeface="Inter"/>
+                <a:sym typeface="Inter"/>
+              </a:rPr>
+              <a:t>Поставьте на слайд QR-код со ссылкой на ваши дополнительные материалы или вышлите вторую версию презентации, в которой будет информация для чтения.</a:t>
+            </a:r>
+            <a:endParaRPr>
+              <a:solidFill>
+                <a:srgbClr val="080040"/>
+              </a:solidFill>
+              <a:latin typeface="Inter"/>
+              <a:ea typeface="Inter"/>
+              <a:cs typeface="Inter"/>
+              <a:sym typeface="Inter"/>
+            </a:endParaRPr>
+          </a:p>
+          <a:p>
+            <a:pPr indent="0" lvl="0" marL="0" rtl="0" algn="l">
+              <a:spcBef>
+                <a:spcPts val="1000"/>
+              </a:spcBef>
+              <a:spcAft>
+                <a:spcPts val="1000"/>
+              </a:spcAft>
+              <a:buNone/>
+            </a:pPr>
+            <a:r>
+              <a:rPr b="1" lang="ru">
+                <a:solidFill>
+                  <a:srgbClr val="FF067E"/>
+                </a:solidFill>
+                <a:latin typeface="Inter"/>
+                <a:ea typeface="Inter"/>
+                <a:cs typeface="Inter"/>
+                <a:sym typeface="Inter"/>
+              </a:rPr>
+              <a:t>Что делать, если нет времени учить?</a:t>
+            </a:r>
+            <a:br>
+              <a:rPr lang="ru">
+                <a:solidFill>
+                  <a:srgbClr val="080040"/>
+                </a:solidFill>
+                <a:latin typeface="Inter"/>
+                <a:ea typeface="Inter"/>
+                <a:cs typeface="Inter"/>
+                <a:sym typeface="Inter"/>
+              </a:rPr>
+            </a:br>
+            <a:r>
+              <a:rPr lang="ru">
+                <a:solidFill>
+                  <a:srgbClr val="080040"/>
+                </a:solidFill>
+                <a:latin typeface="Inter"/>
+                <a:ea typeface="Inter"/>
+                <a:cs typeface="Inter"/>
+                <a:sym typeface="Inter"/>
+              </a:rPr>
+              <a:t>Можно закачать информацию в свой телефон или распечатать небольшие карточки. Так вы будете выглядеть подготовленным в отличие от ситуации, когда вы читаете со слайда, развернувшись к зрителям боком или спиной.</a:t>
+            </a:r>
+            <a:endParaRPr>
+              <a:solidFill>
+                <a:srgbClr val="080040"/>
+              </a:solidFill>
+              <a:latin typeface="Inter"/>
+              <a:ea typeface="Inter"/>
+              <a:cs typeface="Inter"/>
+              <a:sym typeface="Inter"/>
+            </a:endParaRPr>
+          </a:p>
+        </p:txBody>
+      </p:sp>
+      <p:sp>
+        <p:nvSpPr>
+          <p:cNvPr id="423" name="Google Shape;423;p63"/>
+          <p:cNvSpPr txBox="1"/>
+          <p:nvPr>
+            <p:ph idx="12" type="sldNum"/>
+          </p:nvPr>
+        </p:nvSpPr>
+        <p:spPr>
+          <a:xfrm>
+            <a:off x="96504" y="4840516"/>
+            <a:ext cx="548700" cy="393600"/>
+          </a:xfrm>
+          <a:prstGeom prst="rect">
+            <a:avLst/>
+          </a:prstGeom>
+        </p:spPr>
+        <p:txBody>
+          <a:bodyPr anchorCtr="0" anchor="ctr" bIns="91425" lIns="91425" spcFirstLastPara="1" rIns="91425" wrap="square" tIns="91425">
+            <a:normAutofit/>
+          </a:bodyPr>
+          <a:lstStyle/>
+          <a:p>
+            <a:pPr indent="0" lvl="0" marL="0" rtl="0" algn="l">
+              <a:spcBef>
+                <a:spcPts val="0"/>
+              </a:spcBef>
+              <a:spcAft>
+                <a:spcPts val="0"/>
+              </a:spcAft>
+              <a:buNone/>
+            </a:pPr>
+            <a:fld id="{00000000-1234-1234-1234-123412341234}" type="slidenum">
+              <a:rPr lang="ru">
+                <a:solidFill>
+                  <a:srgbClr val="D4D3E2"/>
+                </a:solidFill>
+              </a:rPr>
+              <a:t>‹#›</a:t>
+            </a:fld>
+            <a:endParaRPr>
+              <a:solidFill>
+                <a:srgbClr val="D4D3E2"/>
+              </a:solidFill>
+            </a:endParaRPr>
+          </a:p>
+        </p:txBody>
+      </p:sp>
+    </p:spTree>
+  </p:cSld>
+  <p:clrMapOvr>
+    <a:masterClrMapping/>
+  </p:clrMapOvr>
+</p:sld>
+</file>
+
+<file path=ppt/slides/slide68.xml><?xml version="1.0" encoding="utf-8"?>
+<p:sld xmlns:a="http://schemas.openxmlformats.org/drawingml/2006/main" xmlns:r="http://schemas.openxmlformats.org/officeDocument/2006/relationships" xmlns:mc="http://schemas.openxmlformats.org/markup-compatibility/2006" xmlns:mv="urn:schemas-microsoft-com:mac:vml" xmlns:p="http://schemas.openxmlformats.org/presentationml/2006/main" xmlns:c="http://schemas.openxmlformats.org/drawingml/2006/chart" xmlns:dgm="http://schemas.openxmlformats.org/drawingml/2006/diagram" xmlns:o="urn:schemas-microsoft-com:office:office" xmlns:v="urn:schemas-microsoft-com:vml" xmlns:pvml="urn:schemas-microsoft-com:office:powerpoint" xmlns:com="http://schemas.openxmlformats.org/drawingml/2006/compatibility" xmlns:p14="http://schemas.microsoft.com/office/powerpoint/2010/main" xmlns:p15="http://schemas.microsoft.com/office/powerpoint/2012/main" xmlns:ahyp="http://schemas.microsoft.com/office/drawing/2018/hyperlinkcolor">
+  <p:cSld>
+    <p:bg>
+      <p:bgPr>
+        <a:solidFill>
+          <a:srgbClr val="F2FAFF"/>
+        </a:solidFill>
+      </p:bgPr>
+    </p:bg>
+    <p:spTree>
+      <p:nvGrpSpPr>
+        <p:cNvPr id="539" name="Shape 539"/>
+        <p:cNvGrpSpPr/>
+        <p:nvPr/>
+      </p:nvGrpSpPr>
+      <p:grpSpPr>
+        <a:xfrm>
+          <a:off x="0" y="0"/>
+          <a:ext cx="0" cy="0"/>
+          <a:chOff x="0" y="0"/>
+          <a:chExt cx="0" cy="0"/>
+        </a:xfrm>
+      </p:grpSpPr>
+      <p:sp>
+        <p:nvSpPr>
+          <p:cNvPr id="540" name="Google Shape;540;p80"/>
+          <p:cNvSpPr txBox="1"/>
+          <p:nvPr/>
+        </p:nvSpPr>
+        <p:spPr>
+          <a:xfrm>
+            <a:off x="67675" y="84600"/>
+            <a:ext cx="6647700" cy="677100"/>
+          </a:xfrm>
+          <a:prstGeom prst="rect">
+            <a:avLst/>
+          </a:prstGeom>
+          <a:noFill/>
+          <a:ln>
+            <a:noFill/>
+          </a:ln>
+        </p:spPr>
+        <p:txBody>
+          <a:bodyPr anchorCtr="0" anchor="t" bIns="91425" lIns="91425" spcFirstLastPara="1" rIns="91425" wrap="square" tIns="91425">
+            <a:spAutoFit/>
+          </a:bodyPr>
+          <a:lstStyle/>
+          <a:p>
+            <a:pPr indent="0" lvl="0" marL="0" rtl="0" algn="l">
+              <a:lnSpc>
+                <a:spcPct val="80000"/>
+              </a:lnSpc>
+              <a:spcBef>
+                <a:spcPts val="0"/>
+              </a:spcBef>
+              <a:spcAft>
+                <a:spcPts val="0"/>
+              </a:spcAft>
+              <a:buClr>
+                <a:schemeClr val="dk1"/>
+              </a:buClr>
+              <a:buSzPts val="1100"/>
+              <a:buFont typeface="Arial"/>
+              <a:buNone/>
+            </a:pPr>
+            <a:r>
+              <a:rPr b="1" lang="ru" sz="4000">
+                <a:solidFill>
+                  <a:srgbClr val="080040"/>
+                </a:solidFill>
+                <a:latin typeface="JetBrains Mono"/>
+                <a:ea typeface="JetBrains Mono"/>
+                <a:cs typeface="JetBrains Mono"/>
+                <a:sym typeface="JetBrains Mono"/>
+              </a:rPr>
+              <a:t>Картинка с колонками</a:t>
+            </a:r>
+            <a:endParaRPr b="1" sz="4000">
+              <a:solidFill>
+                <a:srgbClr val="080040"/>
+              </a:solidFill>
+              <a:latin typeface="JetBrains Mono"/>
+              <a:ea typeface="JetBrains Mono"/>
+              <a:cs typeface="JetBrains Mono"/>
+              <a:sym typeface="JetBrains Mono"/>
+            </a:endParaRPr>
+          </a:p>
+        </p:txBody>
+      </p:sp>
+      <p:sp>
+        <p:nvSpPr>
+          <p:cNvPr id="541" name="Google Shape;541;p80"/>
+          <p:cNvSpPr txBox="1"/>
+          <p:nvPr/>
+        </p:nvSpPr>
+        <p:spPr>
+          <a:xfrm>
+            <a:off x="97375" y="3954995"/>
+            <a:ext cx="4379400" cy="1080300"/>
+          </a:xfrm>
+          <a:prstGeom prst="rect">
+            <a:avLst/>
+          </a:prstGeom>
+          <a:noFill/>
+          <a:ln>
+            <a:noFill/>
+          </a:ln>
+        </p:spPr>
+        <p:txBody>
+          <a:bodyPr anchorCtr="0" anchor="t" bIns="91425" lIns="91425" spcFirstLastPara="1" rIns="91425" wrap="square" tIns="91425">
+            <a:noAutofit/>
+          </a:bodyPr>
+          <a:lstStyle/>
+          <a:p>
+            <a:pPr indent="0" lvl="0" marL="0" rtl="0" algn="l">
+              <a:spcBef>
+                <a:spcPts val="0"/>
+              </a:spcBef>
+              <a:spcAft>
+                <a:spcPts val="1000"/>
+              </a:spcAft>
+              <a:buNone/>
+            </a:pPr>
+            <a:r>
+              <a:rPr lang="ru">
+                <a:solidFill>
+                  <a:srgbClr val="080040"/>
+                </a:solidFill>
+                <a:latin typeface="Inter"/>
+                <a:ea typeface="Inter"/>
+                <a:cs typeface="Inter"/>
+                <a:sym typeface="Inter"/>
+              </a:rPr>
+              <a:t>Изучить рекомендации, которые основываются на статистике взаимодействия пользователя с похожими товарами или с теми, которые обычно покупаются в одной </a:t>
+            </a:r>
+            <a:endParaRPr>
+              <a:solidFill>
+                <a:srgbClr val="080040"/>
+              </a:solidFill>
+              <a:latin typeface="Inter"/>
+              <a:ea typeface="Inter"/>
+              <a:cs typeface="Inter"/>
+              <a:sym typeface="Inter"/>
+            </a:endParaRPr>
+          </a:p>
+        </p:txBody>
+      </p:sp>
+      <p:sp>
+        <p:nvSpPr>
+          <p:cNvPr id="542" name="Google Shape;542;p80"/>
+          <p:cNvSpPr txBox="1"/>
+          <p:nvPr/>
+        </p:nvSpPr>
+        <p:spPr>
+          <a:xfrm>
+            <a:off x="4574100" y="3954995"/>
+            <a:ext cx="4379400" cy="1080300"/>
+          </a:xfrm>
+          <a:prstGeom prst="rect">
+            <a:avLst/>
+          </a:prstGeom>
+          <a:noFill/>
+          <a:ln>
+            <a:noFill/>
+          </a:ln>
+        </p:spPr>
+        <p:txBody>
+          <a:bodyPr anchorCtr="0" anchor="t" bIns="91425" lIns="91425" spcFirstLastPara="1" rIns="91425" wrap="square" tIns="91425">
+            <a:noAutofit/>
+          </a:bodyPr>
+          <a:lstStyle/>
+          <a:p>
+            <a:pPr indent="0" lvl="0" marL="0" rtl="0" algn="l">
+              <a:spcBef>
+                <a:spcPts val="0"/>
+              </a:spcBef>
+              <a:spcAft>
+                <a:spcPts val="1000"/>
+              </a:spcAft>
+              <a:buNone/>
+            </a:pPr>
+            <a:r>
+              <a:rPr lang="ru">
+                <a:solidFill>
+                  <a:srgbClr val="080040"/>
+                </a:solidFill>
+                <a:latin typeface="Inter"/>
+                <a:ea typeface="Inter"/>
+                <a:cs typeface="Inter"/>
+                <a:sym typeface="Inter"/>
+              </a:rPr>
+              <a:t>Изучить рекомендации, которые основываются на статистике взаимодействия пользователя с похожими товарами или с теми, которые обычно покупаются в одной </a:t>
+            </a:r>
+            <a:endParaRPr>
+              <a:solidFill>
+                <a:srgbClr val="080040"/>
+              </a:solidFill>
+              <a:latin typeface="Inter"/>
+              <a:ea typeface="Inter"/>
+              <a:cs typeface="Inter"/>
+              <a:sym typeface="Inter"/>
+            </a:endParaRPr>
+          </a:p>
+        </p:txBody>
+      </p:sp>
+      <p:sp>
+        <p:nvSpPr>
+          <p:cNvPr id="543" name="Google Shape;543;p80"/>
+          <p:cNvSpPr/>
+          <p:nvPr/>
+        </p:nvSpPr>
+        <p:spPr>
+          <a:xfrm>
+            <a:off x="190500" y="857250"/>
+            <a:ext cx="8763000" cy="3054600"/>
+          </a:xfrm>
+          <a:prstGeom prst="rect">
+            <a:avLst/>
+          </a:prstGeom>
+          <a:solidFill>
+            <a:srgbClr val="080040"/>
+          </a:solidFill>
+          <a:ln>
+            <a:noFill/>
+          </a:ln>
+        </p:spPr>
+        <p:txBody>
+          <a:bodyPr anchorCtr="0" anchor="ctr" bIns="91425" lIns="91425" spcFirstLastPara="1" rIns="91425" wrap="square" tIns="91425">
+            <a:noAutofit/>
+          </a:bodyPr>
+          <a:lstStyle/>
+          <a:p>
+            <a:pPr indent="0" lvl="0" marL="0" rtl="0" algn="ctr">
+              <a:spcBef>
+                <a:spcPts val="0"/>
+              </a:spcBef>
+              <a:spcAft>
+                <a:spcPts val="0"/>
+              </a:spcAft>
+              <a:buNone/>
+            </a:pPr>
+            <a:r>
+              <a:t/>
+            </a:r>
+            <a:endParaRPr>
+              <a:solidFill>
+                <a:srgbClr val="080040"/>
+              </a:solidFill>
+            </a:endParaRPr>
+          </a:p>
+        </p:txBody>
+      </p:sp>
+      <p:sp>
+        <p:nvSpPr>
+          <p:cNvPr id="544" name="Google Shape;544;p80"/>
+          <p:cNvSpPr txBox="1"/>
+          <p:nvPr>
+            <p:ph idx="12" type="sldNum"/>
+          </p:nvPr>
+        </p:nvSpPr>
+        <p:spPr>
+          <a:xfrm>
+            <a:off x="96504" y="4840516"/>
+            <a:ext cx="548700" cy="393600"/>
+          </a:xfrm>
+          <a:prstGeom prst="rect">
+            <a:avLst/>
+          </a:prstGeom>
+        </p:spPr>
+        <p:txBody>
+          <a:bodyPr anchorCtr="0" anchor="ctr" bIns="91425" lIns="91425" spcFirstLastPara="1" rIns="91425" wrap="square" tIns="91425">
+            <a:normAutofit/>
+          </a:bodyPr>
+          <a:lstStyle/>
+          <a:p>
+            <a:pPr indent="0" lvl="0" marL="0" rtl="0" algn="l">
+              <a:spcBef>
+                <a:spcPts val="0"/>
+              </a:spcBef>
+              <a:spcAft>
+                <a:spcPts val="0"/>
+              </a:spcAft>
+              <a:buNone/>
+            </a:pPr>
+            <a:fld id="{00000000-1234-1234-1234-123412341234}" type="slidenum">
+              <a:rPr lang="ru">
+                <a:solidFill>
+                  <a:srgbClr val="D4D3E2"/>
+                </a:solidFill>
+              </a:rPr>
+              <a:t>‹#›</a:t>
+            </a:fld>
+            <a:endParaRPr>
+              <a:solidFill>
+                <a:srgbClr val="D4D3E2"/>
+              </a:solidFill>
+            </a:endParaRPr>
+          </a:p>
+        </p:txBody>
+      </p:sp>
+    </p:spTree>
+  </p:cSld>
+  <p:clrMapOvr>
+    <a:masterClrMapping/>
+  </p:clrMapOvr>
+</p:sld>
+</file>
+
+<file path=ppt/slides/slide87.xml><?xml version="1.0" encoding="utf-8"?>
+<p:sld xmlns:a="http://schemas.openxmlformats.org/drawingml/2006/main" xmlns:r="http://schemas.openxmlformats.org/officeDocument/2006/relationships" xmlns:mc="http://schemas.openxmlformats.org/markup-compatibility/2006" xmlns:mv="urn:schemas-microsoft-com:mac:vml" xmlns:p="http://schemas.openxmlformats.org/presentationml/2006/main" xmlns:c="http://schemas.openxmlformats.org/drawingml/2006/chart" xmlns:dgm="http://schemas.openxmlformats.org/drawingml/2006/diagram" xmlns:o="urn:schemas-microsoft-com:office:office" xmlns:v="urn:schemas-microsoft-com:vml" xmlns:pvml="urn:schemas-microsoft-com:office:powerpoint" xmlns:com="http://schemas.openxmlformats.org/drawingml/2006/compatibility" xmlns:p14="http://schemas.microsoft.com/office/powerpoint/2010/main" xmlns:p15="http://schemas.microsoft.com/office/powerpoint/2012/main" xmlns:ahyp="http://schemas.microsoft.com/office/drawing/2018/hyperlinkcolor">
+  <p:cSld>
+    <p:bg>
+      <p:bgPr>
+        <a:solidFill>
+          <a:srgbClr val="F2FAFF"/>
+        </a:solidFill>
+      </p:bgPr>
+    </p:bg>
+    <p:spTree>
+      <p:nvGrpSpPr>
+        <p:cNvPr id="686" name="Shape 686"/>
+        <p:cNvGrpSpPr/>
+        <p:nvPr/>
+      </p:nvGrpSpPr>
+      <p:grpSpPr>
+        <a:xfrm>
+          <a:off x="0" y="0"/>
+          <a:ext cx="0" cy="0"/>
+          <a:chOff x="0" y="0"/>
+          <a:chExt cx="0" cy="0"/>
+        </a:xfrm>
+      </p:grpSpPr>
+      <p:sp>
+        <p:nvSpPr>
+          <p:cNvPr id="687" name="Google Shape;687;p99"/>
+          <p:cNvSpPr txBox="1"/>
+          <p:nvPr/>
+        </p:nvSpPr>
+        <p:spPr>
+          <a:xfrm>
+            <a:off x="67675" y="84600"/>
+            <a:ext cx="6647700" cy="677100"/>
+          </a:xfrm>
+          <a:prstGeom prst="rect">
+            <a:avLst/>
+          </a:prstGeom>
+          <a:noFill/>
+          <a:ln>
+            <a:noFill/>
+          </a:ln>
+        </p:spPr>
+        <p:txBody>
+          <a:bodyPr anchorCtr="0" anchor="t" bIns="91425" lIns="91425" spcFirstLastPara="1" rIns="91425" wrap="square" tIns="91425">
+            <a:spAutoFit/>
+          </a:bodyPr>
+          <a:lstStyle/>
+          <a:p>
+            <a:pPr indent="0" lvl="0" marL="0" rtl="0" algn="l">
+              <a:lnSpc>
+                <a:spcPct val="80000"/>
+              </a:lnSpc>
+              <a:spcBef>
+                <a:spcPts val="0"/>
+              </a:spcBef>
+              <a:spcAft>
+                <a:spcPts val="0"/>
+              </a:spcAft>
+              <a:buClr>
+                <a:schemeClr val="dk1"/>
+              </a:buClr>
+              <a:buSzPts val="1100"/>
+              <a:buFont typeface="Arial"/>
+              <a:buNone/>
+            </a:pPr>
+            <a:r>
+              <a:rPr b="1" lang="ru" sz="4000">
+                <a:solidFill>
+                  <a:srgbClr val="080040"/>
+                </a:solidFill>
+                <a:latin typeface="JetBrains Mono"/>
+                <a:ea typeface="JetBrains Mono"/>
+                <a:cs typeface="JetBrains Mono"/>
+                <a:sym typeface="JetBrains Mono"/>
+              </a:rPr>
+              <a:t>Плитка</a:t>
+            </a:r>
+            <a:endParaRPr b="1" sz="4000">
+              <a:solidFill>
+                <a:srgbClr val="080040"/>
+              </a:solidFill>
+              <a:latin typeface="JetBrains Mono"/>
+              <a:ea typeface="JetBrains Mono"/>
+              <a:cs typeface="JetBrains Mono"/>
+              <a:sym typeface="JetBrains Mono"/>
+            </a:endParaRPr>
+          </a:p>
+        </p:txBody>
+      </p:sp>
+      <p:graphicFrame>
+        <p:nvGraphicFramePr>
+          <p:cNvPr id="688" name="Google Shape;688;p99"/>
+          <p:cNvGraphicFramePr/>
+          <p:nvPr/>
+        </p:nvGraphicFramePr>
+        <p:xfrm>
+          <a:off x="-3" y="1333507"/>
+          <a:ext cx="3000000" cy="3000000"/>
+        </p:xfrm>
+        <a:graphic>
+          <a:graphicData uri="http://schemas.openxmlformats.org/drawingml/2006/table">
+            <a:tbl>
+              <a:tblPr>
+                <a:noFill/>
+                <a:tableStyleId>{3ABBAAAA-1E64-43C2-B3C9-485A469EB833}</a:tableStyleId>
+              </a:tblPr>
+              <a:tblGrid>
+                <a:gridCol w="4572000"/>
+                <a:gridCol w="4572000"/>
+              </a:tblGrid>
+              <a:tr h="1905000">
+                <a:tc>
+                  <a:txBody>
+                    <a:bodyPr/>
+                    <a:lstStyle/>
+                    <a:p>
+                      <a:pPr indent="0" lvl="0" marL="0" rtl="0" algn="l">
+                        <a:lnSpc>
+                          <a:spcPct val="100000"/>
+                        </a:lnSpc>
+                        <a:spcBef>
+                          <a:spcPts val="0"/>
+                        </a:spcBef>
+                        <a:spcAft>
+                          <a:spcPts val="0"/>
+                        </a:spcAft>
+                        <a:buNone/>
+                      </a:pPr>
+                      <a:r>
+                        <a:rPr b="1" lang="ru" sz="2000">
+                          <a:solidFill>
+                            <a:srgbClr val="080040"/>
+                          </a:solidFill>
+                          <a:latin typeface="JetBrains Mono"/>
+                          <a:ea typeface="JetBrains Mono"/>
+                          <a:cs typeface="JetBrains Mono"/>
+                          <a:sym typeface="JetBrains Mono"/>
+                        </a:rPr>
+                        <a:t>Заголовок плитки</a:t>
+                      </a:r>
+                      <a:endParaRPr b="1">
+                        <a:solidFill>
+                          <a:srgbClr val="080040"/>
+                        </a:solidFill>
+                        <a:latin typeface="JetBrains Mono"/>
+                        <a:ea typeface="JetBrains Mono"/>
+                        <a:cs typeface="JetBrains Mono"/>
+                        <a:sym typeface="JetBrains Mono"/>
+                      </a:endParaRPr>
+                    </a:p>
+                    <a:p>
+                      <a:pPr indent="0" lvl="0" marL="0" rtl="0" algn="l">
+                        <a:lnSpc>
+                          <a:spcPct val="100000"/>
+                        </a:lnSpc>
+                        <a:spcBef>
+                          <a:spcPts val="1000"/>
+                        </a:spcBef>
+                        <a:spcAft>
+                          <a:spcPts val="1000"/>
+                        </a:spcAft>
+                        <a:buClr>
+                          <a:schemeClr val="dk1"/>
+                        </a:buClr>
+                        <a:buSzPts val="1100"/>
+                        <a:buFont typeface="Arial"/>
+                        <a:buNone/>
+                      </a:pPr>
+                      <a:r>
+                        <a:rPr lang="ru">
+                          <a:solidFill>
+                            <a:srgbClr val="080040"/>
+                          </a:solidFill>
+                          <a:latin typeface="Inter"/>
+                          <a:ea typeface="Inter"/>
+                          <a:cs typeface="Inter"/>
+                          <a:sym typeface="Inter"/>
+                        </a:rPr>
+                        <a:t>Поставьте на слайд QR-код со ссылкой на ваши дополнительные материалы или вышлите вторую версию презентации, в которой будет информация для чтения.</a:t>
+                      </a:r>
+                      <a:endParaRPr sz="1000">
+                        <a:solidFill>
+                          <a:srgbClr val="080040"/>
+                        </a:solidFill>
+                        <a:latin typeface="Inter"/>
+                        <a:ea typeface="Inter"/>
+                        <a:cs typeface="Inter"/>
+                        <a:sym typeface="Inter"/>
+                      </a:endParaRPr>
+                    </a:p>
+                  </a:txBody>
+                  <a:tcPr marT="0" marB="190500" marR="381000" marL="190500">
+                    <a:lnL cap="flat" cmpd="sng" w="114300">
+                      <a:solidFill>
+                        <a:srgbClr val="F2FAFF">
+                          <a:alpha val="0"/>
+                        </a:srgbClr>
+                      </a:solidFill>
+                      <a:prstDash val="solid"/>
+                      <a:round/>
+                      <a:headEnd len="sm" w="sm" type="none"/>
+                      <a:tailEnd len="sm" w="sm" type="none"/>
+                    </a:lnL>
+                    <a:lnR cap="flat" cmpd="sng" w="9525">
+                      <a:solidFill>
+                        <a:srgbClr val="D4D3E2"/>
+                      </a:solidFill>
+                      <a:prstDash val="solid"/>
+                      <a:round/>
+                      <a:headEnd len="sm" w="sm" type="none"/>
+                      <a:tailEnd len="sm" w="sm" type="none"/>
+                    </a:lnR>
+                    <a:lnT cap="flat" cmpd="sng" w="9525">
+                      <a:solidFill>
+                        <a:srgbClr val="CCCCCC">
+                          <a:alpha val="0"/>
+                        </a:srgbClr>
+                      </a:solidFill>
+                      <a:prstDash val="solid"/>
+                      <a:round/>
+                      <a:headEnd len="sm" w="sm" type="none"/>
+                      <a:tailEnd len="sm" w="sm" type="none"/>
+                    </a:lnT>
+                    <a:lnB cap="flat" cmpd="sng" w="9525">
+                      <a:solidFill>
+                        <a:srgbClr val="D4D3E2"/>
+                      </a:solidFill>
+                      <a:prstDash val="solid"/>
+                      <a:round/>
+                      <a:headEnd len="sm" w="sm" type="none"/>
+                      <a:tailEnd len="sm" w="sm" type="none"/>
+                    </a:lnB>
+                  </a:tcPr>
+                </a:tc>
+                <a:tc>
+                  <a:txBody>
+                    <a:bodyPr/>
+                    <a:lstStyle/>
+                    <a:p>
+                      <a:pPr indent="0" lvl="0" marL="0" rtl="0" algn="l">
+                        <a:spcBef>
+                          <a:spcPts val="0"/>
+                        </a:spcBef>
+                        <a:spcAft>
+                          <a:spcPts val="0"/>
+                        </a:spcAft>
+                        <a:buClr>
+                          <a:schemeClr val="dk1"/>
+                        </a:buClr>
+                        <a:buSzPts val="1100"/>
+                        <a:buFont typeface="Arial"/>
+                        <a:buNone/>
+                      </a:pPr>
+                      <a:r>
+                        <a:rPr b="1" lang="ru" sz="2000">
+                          <a:solidFill>
+                            <a:srgbClr val="080040"/>
+                          </a:solidFill>
+                          <a:latin typeface="JetBrains Mono"/>
+                          <a:ea typeface="JetBrains Mono"/>
+                          <a:cs typeface="JetBrains Mono"/>
+                          <a:sym typeface="JetBrains Mono"/>
+                        </a:rPr>
+                        <a:t>Заголовок плитки</a:t>
+                      </a:r>
+                      <a:endParaRPr b="1">
+                        <a:solidFill>
+                          <a:srgbClr val="080040"/>
+                        </a:solidFill>
+                        <a:latin typeface="JetBrains Mono"/>
+                        <a:ea typeface="JetBrains Mono"/>
+                        <a:cs typeface="JetBrains Mono"/>
+                        <a:sym typeface="JetBrains Mono"/>
+                      </a:endParaRPr>
+                    </a:p>
+                    <a:p>
+                      <a:pPr indent="0" lvl="0" marL="0" rtl="0" algn="l">
+                        <a:spcBef>
+                          <a:spcPts val="1000"/>
+                        </a:spcBef>
+                        <a:spcAft>
+                          <a:spcPts val="1000"/>
+                        </a:spcAft>
+                        <a:buClr>
+                          <a:schemeClr val="dk1"/>
+                        </a:buClr>
+                        <a:buSzPts val="1100"/>
+                        <a:buFont typeface="Arial"/>
+                        <a:buNone/>
+                      </a:pPr>
+                      <a:r>
+                        <a:rPr lang="ru">
+                          <a:solidFill>
+                            <a:srgbClr val="080040"/>
+                          </a:solidFill>
+                          <a:latin typeface="Inter"/>
+                          <a:ea typeface="Inter"/>
+                          <a:cs typeface="Inter"/>
+                          <a:sym typeface="Inter"/>
+                        </a:rPr>
+                        <a:t>Поставьте на слайд QR-код со ссылкой на ваши дополнительные материалы или вышлите вторую версию презентации, в которой будет информация для чтения. </a:t>
+                      </a:r>
+                      <a:endParaRPr b="1">
+                        <a:solidFill>
+                          <a:srgbClr val="080040"/>
+                        </a:solidFill>
+                        <a:latin typeface="JetBrains Mono"/>
+                        <a:ea typeface="JetBrains Mono"/>
+                        <a:cs typeface="JetBrains Mono"/>
+                        <a:sym typeface="JetBrains Mono"/>
+                      </a:endParaRPr>
+                    </a:p>
+                  </a:txBody>
+                  <a:tcPr marT="0" marB="190500" marR="381000" marL="190500">
+                    <a:lnL cap="flat" cmpd="sng" w="9525">
+                      <a:solidFill>
+                        <a:srgbClr val="D4D3E2"/>
+                      </a:solidFill>
+                      <a:prstDash val="solid"/>
+                      <a:round/>
+                      <a:headEnd len="sm" w="sm" type="none"/>
+                      <a:tailEnd len="sm" w="sm" type="none"/>
+                    </a:lnL>
+                    <a:lnR cap="flat" cmpd="sng" w="9525">
+                      <a:solidFill>
+                        <a:srgbClr val="D4D3E2"/>
+                      </a:solidFill>
+                      <a:prstDash val="solid"/>
+                      <a:round/>
+                      <a:headEnd len="sm" w="sm" type="none"/>
+                      <a:tailEnd len="sm" w="sm" type="none"/>
+                    </a:lnR>
+                    <a:lnT cap="flat" cmpd="sng" w="9525">
+                      <a:solidFill>
+                        <a:srgbClr val="CCCCCC">
+                          <a:alpha val="0"/>
+                        </a:srgbClr>
+                      </a:solidFill>
+                      <a:prstDash val="solid"/>
+                      <a:round/>
+                      <a:headEnd len="sm" w="sm" type="none"/>
+                      <a:tailEnd len="sm" w="sm" type="none"/>
+                    </a:lnT>
+                    <a:lnB cap="flat" cmpd="sng" w="9525">
+                      <a:solidFill>
+                        <a:srgbClr val="D4D3E2"/>
+                      </a:solidFill>
+                      <a:prstDash val="solid"/>
+                      <a:round/>
+                      <a:headEnd len="sm" w="sm" type="none"/>
+                      <a:tailEnd len="sm" w="sm" type="none"/>
+                    </a:lnB>
+                  </a:tcPr>
+                </a:tc>
+              </a:tr>
+              <a:tr h="1905000">
+                <a:tc>
+                  <a:txBody>
+                    <a:bodyPr/>
+                    <a:lstStyle/>
+                    <a:p>
+                      <a:pPr indent="0" lvl="0" marL="0" rtl="0" algn="l">
+                        <a:spcBef>
+                          <a:spcPts val="0"/>
+                        </a:spcBef>
+                        <a:spcAft>
+                          <a:spcPts val="0"/>
+                        </a:spcAft>
+                        <a:buClr>
+                          <a:schemeClr val="dk1"/>
+                        </a:buClr>
+                        <a:buSzPts val="1100"/>
+                        <a:buFont typeface="Arial"/>
+                        <a:buNone/>
+                      </a:pPr>
+                      <a:r>
+                        <a:rPr b="1" lang="ru" sz="2000">
+                          <a:solidFill>
+                            <a:srgbClr val="080040"/>
+                          </a:solidFill>
+                          <a:latin typeface="JetBrains Mono"/>
+                          <a:ea typeface="JetBrains Mono"/>
+                          <a:cs typeface="JetBrains Mono"/>
+                          <a:sym typeface="JetBrains Mono"/>
+                        </a:rPr>
+                        <a:t>Заголовок плитки</a:t>
+                      </a:r>
+                      <a:endParaRPr b="1">
+                        <a:solidFill>
+                          <a:srgbClr val="080040"/>
+                        </a:solidFill>
+                        <a:latin typeface="JetBrains Mono"/>
+                        <a:ea typeface="JetBrains Mono"/>
+                        <a:cs typeface="JetBrains Mono"/>
+                        <a:sym typeface="JetBrains Mono"/>
+                      </a:endParaRPr>
+                    </a:p>
+                    <a:p>
+                      <a:pPr indent="0" lvl="0" marL="0" rtl="0" algn="l">
+                        <a:spcBef>
+                          <a:spcPts val="1000"/>
+                        </a:spcBef>
+                        <a:spcAft>
+                          <a:spcPts val="1000"/>
+                        </a:spcAft>
+                        <a:buClr>
+                          <a:schemeClr val="dk1"/>
+                        </a:buClr>
+                        <a:buSzPts val="1100"/>
+                        <a:buFont typeface="Arial"/>
+                        <a:buNone/>
+                      </a:pPr>
+                      <a:r>
+                        <a:rPr lang="ru">
+                          <a:solidFill>
+                            <a:srgbClr val="080040"/>
+                          </a:solidFill>
+                          <a:latin typeface="Inter"/>
+                          <a:ea typeface="Inter"/>
+                          <a:cs typeface="Inter"/>
+                          <a:sym typeface="Inter"/>
+                        </a:rPr>
+                        <a:t>Поставьте на слайд QR-код со ссылкой на ваши дополнительные материалы или вышлите вторую версию презентации, в которой будет информация для чтения.</a:t>
+                      </a:r>
+                      <a:endParaRPr b="1">
+                        <a:solidFill>
+                          <a:srgbClr val="080040"/>
+                        </a:solidFill>
+                        <a:latin typeface="JetBrains Mono"/>
+                        <a:ea typeface="JetBrains Mono"/>
+                        <a:cs typeface="JetBrains Mono"/>
+                        <a:sym typeface="JetBrains Mono"/>
+                      </a:endParaRPr>
+                    </a:p>
+                  </a:txBody>
+                  <a:tcPr marT="190500" marB="190500" marR="381000" marL="190500">
+                    <a:lnL cap="flat" cmpd="sng" w="114300">
+                      <a:solidFill>
+                        <a:srgbClr val="F2FAFF">
+                          <a:alpha val="0"/>
+                        </a:srgbClr>
+                      </a:solidFill>
+                      <a:prstDash val="solid"/>
+                      <a:round/>
+                      <a:headEnd len="sm" w="sm" type="none"/>
+                      <a:tailEnd len="sm" w="sm" type="none"/>
+                    </a:lnL>
+                    <a:lnR cap="flat" cmpd="sng" w="9525">
+                      <a:solidFill>
+                        <a:srgbClr val="D4D3E2"/>
+                      </a:solidFill>
+                      <a:prstDash val="solid"/>
+                      <a:round/>
+                      <a:headEnd len="sm" w="sm" type="none"/>
+                      <a:tailEnd len="sm" w="sm" type="none"/>
+                    </a:lnR>
+                    <a:lnT cap="flat" cmpd="sng" w="9525">
+                      <a:solidFill>
+                        <a:srgbClr val="D4D3E2"/>
+                      </a:solidFill>
+                      <a:prstDash val="solid"/>
+                      <a:round/>
+                      <a:headEnd len="sm" w="sm" type="none"/>
+                      <a:tailEnd len="sm" w="sm" type="none"/>
+                    </a:lnT>
+                    <a:lnB cap="flat" cmpd="sng" w="9525">
+                      <a:solidFill>
+                        <a:srgbClr val="CCCCCC">
+                          <a:alpha val="0"/>
+                        </a:srgbClr>
+                      </a:solidFill>
+                      <a:prstDash val="solid"/>
+                      <a:round/>
+                      <a:headEnd len="sm" w="sm" type="none"/>
+                      <a:tailEnd len="sm" w="sm" type="none"/>
+                    </a:lnB>
+                  </a:tcPr>
+                </a:tc>
+                <a:tc>
+                  <a:txBody>
+                    <a:bodyPr/>
+                    <a:lstStyle/>
+                    <a:p>
+                      <a:pPr indent="0" lvl="0" marL="0" rtl="0" algn="l">
+                        <a:spcBef>
+                          <a:spcPts val="0"/>
+                        </a:spcBef>
+                        <a:spcAft>
+                          <a:spcPts val="0"/>
+                        </a:spcAft>
+                        <a:buClr>
+                          <a:schemeClr val="dk1"/>
+                        </a:buClr>
+                        <a:buSzPts val="1100"/>
+                        <a:buFont typeface="Arial"/>
+                        <a:buNone/>
+                      </a:pPr>
+                      <a:r>
+                        <a:rPr b="1" lang="ru" sz="2000">
+                          <a:solidFill>
+                            <a:srgbClr val="080040"/>
+                          </a:solidFill>
+                          <a:latin typeface="JetBrains Mono"/>
+                          <a:ea typeface="JetBrains Mono"/>
+                          <a:cs typeface="JetBrains Mono"/>
+                          <a:sym typeface="JetBrains Mono"/>
+                        </a:rPr>
+                        <a:t>Заголовок плитки</a:t>
+                      </a:r>
+                      <a:endParaRPr b="1">
+                        <a:solidFill>
+                          <a:srgbClr val="080040"/>
+                        </a:solidFill>
+                        <a:latin typeface="JetBrains Mono"/>
+                        <a:ea typeface="JetBrains Mono"/>
+                        <a:cs typeface="JetBrains Mono"/>
+                        <a:sym typeface="JetBrains Mono"/>
+                      </a:endParaRPr>
+                    </a:p>
+                    <a:p>
+                      <a:pPr indent="0" lvl="0" marL="0" rtl="0" algn="l">
+                        <a:spcBef>
+                          <a:spcPts val="1000"/>
+                        </a:spcBef>
+                        <a:spcAft>
+                          <a:spcPts val="1000"/>
+                        </a:spcAft>
+                        <a:buClr>
+                          <a:schemeClr val="dk1"/>
+                        </a:buClr>
+                        <a:buSzPts val="1100"/>
+                        <a:buFont typeface="Arial"/>
+                        <a:buNone/>
+                      </a:pPr>
+                      <a:r>
+                        <a:rPr lang="ru">
+                          <a:solidFill>
+                            <a:srgbClr val="080040"/>
+                          </a:solidFill>
+                          <a:latin typeface="Inter"/>
+                          <a:ea typeface="Inter"/>
+                          <a:cs typeface="Inter"/>
+                          <a:sym typeface="Inter"/>
+                        </a:rPr>
+                        <a:t>Поставьте на слайд QR-код со ссылкой на ваши дополнительные материалы или вышлите вторую версию презентации, в которой будет информация для чтения.</a:t>
+                      </a:r>
+                      <a:endParaRPr b="1">
+                        <a:solidFill>
+                          <a:srgbClr val="080040"/>
+                        </a:solidFill>
+                        <a:latin typeface="JetBrains Mono"/>
+                        <a:ea typeface="JetBrains Mono"/>
+                        <a:cs typeface="JetBrains Mono"/>
+                        <a:sym typeface="JetBrains Mono"/>
+                      </a:endParaRPr>
+                    </a:p>
+                  </a:txBody>
+                  <a:tcPr marT="190500" marB="190500" marR="381000" marL="190500">
+                    <a:lnL cap="flat" cmpd="sng" w="9525">
+                      <a:solidFill>
+                        <a:srgbClr val="D4D3E2"/>
+                      </a:solidFill>
+                      <a:prstDash val="solid"/>
+                      <a:round/>
+                      <a:headEnd len="sm" w="sm" type="none"/>
+                      <a:tailEnd len="sm" w="sm" type="none"/>
+                    </a:lnL>
+                    <a:lnR cap="flat" cmpd="sng" w="9525">
+                      <a:solidFill>
+                        <a:srgbClr val="D4D3E2"/>
+                      </a:solidFill>
+                      <a:prstDash val="solid"/>
+                      <a:round/>
+                      <a:headEnd len="sm" w="sm" type="none"/>
+                      <a:tailEnd len="sm" w="sm" type="none"/>
+                    </a:lnR>
+                    <a:lnT cap="flat" cmpd="sng" w="9525">
+                      <a:solidFill>
+                        <a:srgbClr val="D4D3E2"/>
+                      </a:solidFill>
+                      <a:prstDash val="solid"/>
+                      <a:round/>
+                      <a:headEnd len="sm" w="sm" type="none"/>
+                      <a:tailEnd len="sm" w="sm" type="none"/>
+                    </a:lnT>
+                    <a:lnB cap="flat" cmpd="sng" w="9525">
+                      <a:solidFill>
+                        <a:srgbClr val="CCCCCC">
+                          <a:alpha val="0"/>
+                        </a:srgbClr>
+                      </a:solidFill>
+                      <a:prstDash val="solid"/>
+                      <a:round/>
+                      <a:headEnd len="sm" w="sm" type="none"/>
+                      <a:tailEnd len="sm" w="sm" type="none"/>
+                    </a:lnB>
+                  </a:tcPr>
+                </a:tc>
+              </a:tr>
+            </a:tbl>
+          </a:graphicData>
+        </a:graphic>
+      </p:graphicFrame>
+      <p:sp>
+        <p:nvSpPr>
+          <p:cNvPr id="689" name="Google Shape;689;p99"/>
+          <p:cNvSpPr txBox="1"/>
+          <p:nvPr>
+            <p:ph idx="12" type="sldNum"/>
+          </p:nvPr>
+        </p:nvSpPr>
+        <p:spPr>
+          <a:xfrm>
+            <a:off x="96504" y="4840516"/>
+            <a:ext cx="548700" cy="393600"/>
+          </a:xfrm>
+          <a:prstGeom prst="rect">
+            <a:avLst/>
+          </a:prstGeom>
+        </p:spPr>
+        <p:txBody>
+          <a:bodyPr anchorCtr="0" anchor="ctr" bIns="91425" lIns="91425" spcFirstLastPara="1" rIns="91425" wrap="square" tIns="91425">
+            <a:normAutofit/>
+          </a:bodyPr>
+          <a:lstStyle/>
+          <a:p>
+            <a:pPr indent="0" lvl="0" marL="0" rtl="0" algn="l">
+              <a:spcBef>
+                <a:spcPts val="0"/>
+              </a:spcBef>
+              <a:spcAft>
+                <a:spcPts val="0"/>
+              </a:spcAft>
+              <a:buNone/>
+            </a:pPr>
+            <a:fld id="{00000000-1234-1234-1234-123412341234}" type="slidenum">
+              <a:rPr lang="ru">
+                <a:solidFill>
+                  <a:srgbClr val="D4D3E2"/>
+                </a:solidFill>
+              </a:rPr>
+              <a:t>‹#›</a:t>
+            </a:fld>
+            <a:endParaRPr>
+              <a:solidFill>
+                <a:srgbClr val="D4D3E2"/>
+              </a:solidFill>
+            </a:endParaRPr>
+          </a:p>
+        </p:txBody>
+      </p:sp>
+    </p:spTree>
+  </p:cSld>
+  <p:clrMapOvr>
+    <a:masterClrMapping/>
+  </p:clrMapOvr>
+</p:sld>
+</file>
+
 <file path=ppt/theme/theme1.xml><?xml version="1.0" encoding="utf-8"?>
 <a:theme xmlns:a="http://schemas.openxmlformats.org/drawingml/2006/main" xmlns:r="http://schemas.openxmlformats.org/officeDocument/2006/relationships" name="Simple Light">
   <a:themeElements>

</xml_diff>